<commit_message>
docs: update dataset description documents and pipeline deck with age and gender schema (12 columns)
</commit_message>
<xml_diff>
--- a/WorkPulse_Kaggle_Data_Pipeline_Arabic_LargeFont.pptx
+++ b/WorkPulse_Kaggle_Data_Pipeline_Arabic_LargeFont.pptx
@@ -6030,7 +6030,7 @@
                         </a:defRPr>
                       </a:pPr>
                       <a:r>
-                        <a:t>10 أعمدة (أرقام + نصوص)</a:t>
+                        <a:t>12 عموداً (ديموغرافيا + أرقام + نصوص)</a:t>
                       </a:r>
                     </a:p>
                   </a:txBody>
@@ -6054,7 +6054,7 @@
                         </a:defRPr>
                       </a:pPr>
                       <a:r>
-                        <a:t>إضافة طبقة نصوص الـ NLP والأسماء</a:t>
+                        <a:t>إضافة الجنس، العمر، نصوص الـ NLP والأسماء</a:t>
                       </a:r>
                     </a:p>
                   </a:txBody>
@@ -6241,7 +6241,7 @@
               </a:defRPr>
             </a:pPr>
             <a:r>
-              <a:t>2. العينة تضم 1,000 موظف بأسماء عربية فريدة تعبر عن واقع المؤسسات المحلية.</a:t>
+              <a:t>2. العينة تضم 1,000 موظف بأسماء عربية فريدة وبيانات ديموغرافية (النوع والعمر) تعبر عن بيئة العمل الحقيقية.</a:t>
             </a:r>
           </a:p>
           <a:p>
@@ -6362,7 +6362,7 @@
               </a:defRPr>
             </a:pPr>
             <a:r>
-              <a:t>4. جدول مواءمة المتغيرات (Kaggle  ◀  WorkPulse Schema)</a:t>
+              <a:t>4. جدول مواءمة المتغيرات (Kaggle  ◀  Tawazon Schema)</a:t>
             </a:r>
           </a:p>
         </p:txBody>
@@ -6398,7 +6398,7 @@
               </a:defRPr>
             </a:pPr>
             <a:r>
-              <a:t>تحويل أعمدة كاجل إلى مؤشرات الموارد البشرية مع إضافة التشويش الطبيعي (Noise):</a:t>
+              <a:t>تحويل أعمدة كاجل إلى مؤشرات الموارد البشرية والديموغرافيا مع إضافة التشويش الطبيعي (Noise):</a:t>
             </a:r>
           </a:p>
         </p:txBody>
@@ -6413,7 +6413,7 @@
         </p:nvGraphicFramePr>
         <p:xfrm>
           <a:off x="457200" y="1143000"/>
-          <a:ext cx="11274552" cy="3822191"/>
+          <a:ext cx="11274552" cy="4041648"/>
         </p:xfrm>
         <a:graphic>
           <a:graphicData uri="http://schemas.openxmlformats.org/drawingml/2006/table">
@@ -6427,7 +6427,7 @@
                 <a:gridCol w="2818638"/>
                 <a:gridCol w="2818638"/>
               </a:tblGrid>
-              <a:tr h="347471">
+              <a:tr h="310896">
                 <a:tc>
                   <a:txBody>
                     <a:bodyPr/>
@@ -6442,7 +6442,7 @@
                         </a:defRPr>
                       </a:pPr>
                       <a:r>
-                        <a:t>عمود نظام WorkPulse</a:t>
+                        <a:t>عمود نظام Tawazon</a:t>
                       </a:r>
                     </a:p>
                   </a:txBody>
@@ -6525,7 +6525,7 @@
                   </a:tcPr>
                 </a:tc>
               </a:tr>
-              <a:tr h="347471">
+              <a:tr h="310896">
                 <a:tc>
                   <a:txBody>
                     <a:bodyPr/>
@@ -6623,7 +6623,7 @@
                   </a:tcPr>
                 </a:tc>
               </a:tr>
-              <a:tr h="347471">
+              <a:tr h="310896">
                 <a:tc>
                   <a:txBody>
                     <a:bodyPr/>
@@ -6721,7 +6721,7 @@
                   </a:tcPr>
                 </a:tc>
               </a:tr>
-              <a:tr h="347471">
+              <a:tr h="310896">
                 <a:tc>
                   <a:txBody>
                     <a:bodyPr/>
@@ -6736,6 +6736,202 @@
                         </a:defRPr>
                       </a:pPr>
                       <a:r>
+                        <a:t>gender</a:t>
+                      </a:r>
+                    </a:p>
+                  </a:txBody>
+                  <a:tcPr>
+                    <a:solidFill>
+                      <a:srgbClr val="1E293B"/>
+                    </a:solidFill>
+                  </a:tcPr>
+                </a:tc>
+                <a:tc>
+                  <a:txBody>
+                    <a:bodyPr/>
+                    <a:lstStyle/>
+                    <a:p>
+                      <a:pPr algn="ctr">
+                        <a:defRPr sz="1200" b="0">
+                          <a:solidFill>
+                            <a:srgbClr val="FFFFFF"/>
+                          </a:solidFill>
+                          <a:latin typeface="Arial"/>
+                        </a:defRPr>
+                      </a:pPr>
+                      <a:r>
+                        <a:t>Gender (موجود في كاجل)</a:t>
+                      </a:r>
+                    </a:p>
+                  </a:txBody>
+                  <a:tcPr>
+                    <a:solidFill>
+                      <a:srgbClr val="1E293B"/>
+                    </a:solidFill>
+                  </a:tcPr>
+                </a:tc>
+                <a:tc>
+                  <a:txBody>
+                    <a:bodyPr/>
+                    <a:lstStyle/>
+                    <a:p>
+                      <a:pPr algn="ctr">
+                        <a:defRPr sz="1200" b="0">
+                          <a:solidFill>
+                            <a:srgbClr val="FFFFFF"/>
+                          </a:solidFill>
+                          <a:latin typeface="Arial"/>
+                        </a:defRPr>
+                      </a:pPr>
+                      <a:r>
+                        <a:t>المحافظة على التوزيع (527 إناث / 473 ذكور)</a:t>
+                      </a:r>
+                    </a:p>
+                  </a:txBody>
+                  <a:tcPr>
+                    <a:solidFill>
+                      <a:srgbClr val="1E293B"/>
+                    </a:solidFill>
+                  </a:tcPr>
+                </a:tc>
+                <a:tc>
+                  <a:txBody>
+                    <a:bodyPr/>
+                    <a:lstStyle/>
+                    <a:p>
+                      <a:pPr algn="ctr">
+                        <a:defRPr sz="1200" b="0">
+                          <a:solidFill>
+                            <a:srgbClr val="FFFFFF"/>
+                          </a:solidFill>
+                          <a:latin typeface="Arial"/>
+                        </a:defRPr>
+                      </a:pPr>
+                      <a:r>
+                        <a:t>Male / Female</a:t>
+                      </a:r>
+                    </a:p>
+                  </a:txBody>
+                  <a:tcPr>
+                    <a:solidFill>
+                      <a:srgbClr val="1E293B"/>
+                    </a:solidFill>
+                  </a:tcPr>
+                </a:tc>
+              </a:tr>
+              <a:tr h="310896">
+                <a:tc>
+                  <a:txBody>
+                    <a:bodyPr/>
+                    <a:lstStyle/>
+                    <a:p>
+                      <a:pPr algn="ctr">
+                        <a:defRPr sz="1200" b="1">
+                          <a:solidFill>
+                            <a:srgbClr val="FFFFFF"/>
+                          </a:solidFill>
+                          <a:latin typeface="Arial"/>
+                        </a:defRPr>
+                      </a:pPr>
+                      <a:r>
+                        <a:t>age</a:t>
+                      </a:r>
+                    </a:p>
+                  </a:txBody>
+                  <a:tcPr>
+                    <a:solidFill>
+                      <a:srgbClr val="0F172A"/>
+                    </a:solidFill>
+                  </a:tcPr>
+                </a:tc>
+                <a:tc>
+                  <a:txBody>
+                    <a:bodyPr/>
+                    <a:lstStyle/>
+                    <a:p>
+                      <a:pPr algn="ctr">
+                        <a:defRPr sz="1200" b="0">
+                          <a:solidFill>
+                            <a:srgbClr val="FFFFFF"/>
+                          </a:solidFill>
+                          <a:latin typeface="Arial"/>
+                        </a:defRPr>
+                      </a:pPr>
+                      <a:r>
+                        <a:t>Designation (المستوى الوظيفي)</a:t>
+                      </a:r>
+                    </a:p>
+                  </a:txBody>
+                  <a:tcPr>
+                    <a:solidFill>
+                      <a:srgbClr val="0F172A"/>
+                    </a:solidFill>
+                  </a:tcPr>
+                </a:tc>
+                <a:tc>
+                  <a:txBody>
+                    <a:bodyPr/>
+                    <a:lstStyle/>
+                    <a:p>
+                      <a:pPr algn="ctr">
+                        <a:defRPr sz="1200" b="0">
+                          <a:solidFill>
+                            <a:srgbClr val="FFFFFF"/>
+                          </a:solidFill>
+                          <a:latin typeface="Arial"/>
+                        </a:defRPr>
+                      </a:pPr>
+                      <a:r>
+                        <a:t>23 + (Designation * 5.2) + Noise</a:t>
+                      </a:r>
+                    </a:p>
+                  </a:txBody>
+                  <a:tcPr>
+                    <a:solidFill>
+                      <a:srgbClr val="0F172A"/>
+                    </a:solidFill>
+                  </a:tcPr>
+                </a:tc>
+                <a:tc>
+                  <a:txBody>
+                    <a:bodyPr/>
+                    <a:lstStyle/>
+                    <a:p>
+                      <a:pPr algn="ctr">
+                        <a:defRPr sz="1200" b="0">
+                          <a:solidFill>
+                            <a:srgbClr val="FFFFFF"/>
+                          </a:solidFill>
+                          <a:latin typeface="Arial"/>
+                        </a:defRPr>
+                      </a:pPr>
+                      <a:r>
+                        <a:t>22 - 56 سنة (متوسط 34.7)</a:t>
+                      </a:r>
+                    </a:p>
+                  </a:txBody>
+                  <a:tcPr>
+                    <a:solidFill>
+                      <a:srgbClr val="0F172A"/>
+                    </a:solidFill>
+                  </a:tcPr>
+                </a:tc>
+              </a:tr>
+              <a:tr h="310896">
+                <a:tc>
+                  <a:txBody>
+                    <a:bodyPr/>
+                    <a:lstStyle/>
+                    <a:p>
+                      <a:pPr algn="ctr">
+                        <a:defRPr sz="1200" b="1">
+                          <a:solidFill>
+                            <a:srgbClr val="FFFFFF"/>
+                          </a:solidFill>
+                          <a:latin typeface="Arial"/>
+                        </a:defRPr>
+                      </a:pPr>
+                      <a:r>
                         <a:t>avg_daily_hours</a:t>
                       </a:r>
                     </a:p>
@@ -6819,7 +7015,7 @@
                   </a:tcPr>
                 </a:tc>
               </a:tr>
-              <a:tr h="347471">
+              <a:tr h="310896">
                 <a:tc>
                   <a:txBody>
                     <a:bodyPr/>
@@ -6917,7 +7113,7 @@
                   </a:tcPr>
                 </a:tc>
               </a:tr>
-              <a:tr h="347471">
+              <a:tr h="310896">
                 <a:tc>
                   <a:txBody>
                     <a:bodyPr/>
@@ -7015,7 +7211,7 @@
                   </a:tcPr>
                 </a:tc>
               </a:tr>
-              <a:tr h="347471">
+              <a:tr h="310896">
                 <a:tc>
                   <a:txBody>
                     <a:bodyPr/>
@@ -7113,7 +7309,7 @@
                   </a:tcPr>
                 </a:tc>
               </a:tr>
-              <a:tr h="347471">
+              <a:tr h="310896">
                 <a:tc>
                   <a:txBody>
                     <a:bodyPr/>
@@ -7211,7 +7407,7 @@
                   </a:tcPr>
                 </a:tc>
               </a:tr>
-              <a:tr h="347471">
+              <a:tr h="310896">
                 <a:tc>
                   <a:txBody>
                     <a:bodyPr/>
@@ -7309,7 +7505,7 @@
                   </a:tcPr>
                 </a:tc>
               </a:tr>
-              <a:tr h="347471">
+              <a:tr h="310896">
                 <a:tc>
                   <a:txBody>
                     <a:bodyPr/>
@@ -7407,7 +7603,7 @@
                   </a:tcPr>
                 </a:tc>
               </a:tr>
-              <a:tr h="347481">
+              <a:tr h="310896">
                 <a:tc>
                   <a:txBody>
                     <a:bodyPr/>

</xml_diff>